<commit_message>
Add proposal PPTX: Abogada Vida PLLC (July 13, 2026)
</commit_message>
<xml_diff>
--- a/abogada-vida/AbogadaVida_July132026_Proposal.pptx
+++ b/abogada-vida/AbogadaVida_July132026_Proposal.pptx
@@ -3541,7 +3541,7 @@
                 </a:solidFill>
                 <a:latin typeface="Calibri"/>
               </a:rPr>
-              <a:t>Not in Allentown 3-pack</a:t>
+              <a:t>No paid ads active</a:t>
             </a:r>
           </a:p>
         </p:txBody>
@@ -3697,7 +3697,7 @@
                 </a:solidFill>
                 <a:latin typeface="Calibri"/>
               </a:rPr>
-              <a:t>IN PROGRESS</a:t>
+              <a:t>AMBER</a:t>
             </a:r>
           </a:p>
         </p:txBody>
@@ -3730,7 +3730,7 @@
                 </a:solidFill>
                 <a:latin typeface="Calibri"/>
               </a:rPr>
-              <a:t>20% lead-to-consult rate</a:t>
+              <a:t>20% booking rate</a:t>
             </a:r>
           </a:p>
         </p:txBody>
@@ -3886,7 +3886,7 @@
                 </a:solidFill>
                 <a:latin typeface="Calibri"/>
               </a:rPr>
-              <a:t>IN PROGRESS</a:t>
+              <a:t>AMBER</a:t>
             </a:r>
           </a:p>
         </p:txBody>
@@ -3919,7 +3919,7 @@
                 </a:solidFill>
                 <a:latin typeface="Calibri"/>
               </a:rPr>
-              <a:t>Sole attorney bottleneck</a:t>
+              <a:t>Solo attorney only</a:t>
             </a:r>
           </a:p>
         </p:txBody>
@@ -4075,7 +4075,7 @@
                 </a:solidFill>
                 <a:latin typeface="Calibri"/>
               </a:rPr>
-              <a:t>IN PROGRESS</a:t>
+              <a:t>AMBER</a:t>
             </a:r>
           </a:p>
         </p:txBody>
@@ -4108,7 +4108,7 @@
                 </a:solidFill>
                 <a:latin typeface="Calibri"/>
               </a:rPr>
-              <a:t>Revenue swings $36K–$66K</a:t>
+              <a:t>$36K–$66K variance</a:t>
             </a:r>
           </a:p>
         </p:txBody>
@@ -4297,7 +4297,7 @@
                 </a:solidFill>
                 <a:latin typeface="Calibri"/>
               </a:rPr>
-              <a:t>Invisible in Allentown search despite 96 five-star reviews — NAP inconsistency suppressing local pack ranking</a:t>
+              <a:t>No Google Ads, LSA, or Meta confirmed — Allentown competitors filling those searches</a:t>
             </a:r>
           </a:p>
         </p:txBody>
@@ -4453,7 +4453,7 @@
                 </a:solidFill>
                 <a:latin typeface="Calibri"/>
               </a:rPr>
-              <a:t>30% of all leads referred out to competitors — no removal defense attorney; Lahoud Law Group captures them</a:t>
+              <a:t>30% of leads referred out — removal and detainee cases going to Lahoud Law Group</a:t>
             </a:r>
           </a:p>
         </p:txBody>
@@ -4609,7 +4609,7 @@
                 </a:solidFill>
                 <a:latin typeface="Calibri"/>
               </a:rPr>
-              <a:t>Lead-to-consult rate 20%; 40-pt gap between Karen (66%) and Gabby (26.7%) on same leads</a:t>
+              <a:t>Intake books 20% of leads vs. Karen's 66% — 80% of lead flow unconverted</a:t>
             </a:r>
           </a:p>
         </p:txBody>
@@ -4765,7 +4765,7 @@
                 </a:solidFill>
                 <a:latin typeface="Calibri"/>
               </a:rPr>
-              <a:t>96 Google reviews at 5.0 stars — more than every local competitor combined</a:t>
+              <a:t>96 Google reviews at 5.0 stars — most reviewed immigration firm in Lehigh Valley</a:t>
             </a:r>
           </a:p>
         </p:txBody>
@@ -5077,7 +5077,7 @@
                 </a:solidFill>
                 <a:latin typeface="Calibri"/>
               </a:rPr>
-              <a:t>Lehigh Valley Immigration</a:t>
+              <a:t>Lehigh Valley Immigration Law LLC</a:t>
             </a:r>
           </a:p>
         </p:txBody>
@@ -5143,7 +5143,7 @@
                 </a:solidFill>
                 <a:latin typeface="Calibri"/>
               </a:rPr>
-              <a:t>Bilingual · 2025 · Allentown</a:t>
+              <a:t>bilingual · Allentown</a:t>
             </a:r>
           </a:p>
         </p:txBody>
@@ -5221,7 +5221,7 @@
                 </a:solidFill>
                 <a:latin typeface="Calibri"/>
               </a:rPr>
-              <a:t>YRV Law</a:t>
+              <a:t>Albarelli &amp; Harrington</a:t>
             </a:r>
           </a:p>
         </p:txBody>
@@ -5254,7 +5254,7 @@
                 </a:solidFill>
                 <a:latin typeface="Calibri"/>
               </a:rPr>
-              <a:t>36 reviews</a:t>
+              <a:t>25+ yrs exp</a:t>
             </a:r>
           </a:p>
         </p:txBody>
@@ -5287,7 +5287,7 @@
                 </a:solidFill>
                 <a:latin typeface="Calibri"/>
               </a:rPr>
-              <a:t>Bilingual · active social</a:t>
+              <a:t>removal · downtown</a:t>
             </a:r>
           </a:p>
         </p:txBody>
@@ -5431,7 +5431,7 @@
                 </a:solidFill>
                 <a:latin typeface="Calibri"/>
               </a:rPr>
-              <a:t>Removal specialist · AILA</a:t>
+              <a:t>deportation · AILA</a:t>
             </a:r>
           </a:p>
         </p:txBody>
@@ -5587,7 +5587,7 @@
                 </a:solidFill>
                 <a:latin typeface="Calibri"/>
               </a:rPr>
-              <a:t>96 reviews</a:t>
+              <a:t>96 reviews · 5.0 ★</a:t>
             </a:r>
           </a:p>
         </p:txBody>
@@ -5620,7 +5620,7 @@
                 </a:solidFill>
                 <a:latin typeface="Calibri"/>
               </a:rPr>
-              <a:t>← You are here</a:t>
+              <a:t>← leads the market</a:t>
             </a:r>
           </a:p>
         </p:txBody>
@@ -5884,7 +5884,7 @@
                 </a:solidFill>
                 <a:latin typeface="Calibri"/>
               </a:rPr>
-              <a:t>Your Growth Plan: 3 Priorities to Reach $1M in Year 1</a:t>
+              <a:t>Your Growth Plan: 3 Priorities to Reach $1M This Year</a:t>
             </a:r>
           </a:p>
         </p:txBody>
@@ -6040,7 +6040,7 @@
                 </a:solidFill>
                 <a:latin typeface="Calibri"/>
               </a:rPr>
-              <a:t>Lead Generation, Intake, Team, and Profit must all work together. None of the four can be skipped. When all four pillars align, Mahsa can build the $1M, $3M, and $7M firm her Vivid Vision already describes — with a team that runs it.</a:t>
+              <a:t>The SMB Team model builds Lead Generation, Intake, Team, and Profit together — all four pillars at once. When all four work, Mahsa can finally step back from being the only attorney and lead a firm that grows without her in every case.</a:t>
             </a:r>
           </a:p>
         </p:txBody>
@@ -6118,7 +6118,7 @@
                 </a:solidFill>
                 <a:latin typeface="Calibri"/>
               </a:rPr>
-              <a:t>$600K → $1M in Year 1</a:t>
+              <a:t>$600K → $1M revenue (Year 1)</a:t>
             </a:r>
           </a:p>
         </p:txBody>
@@ -6151,7 +6151,7 @@
                 </a:solidFill>
                 <a:latin typeface="Calibri"/>
               </a:rPr>
-              <a:t>Lead this market. Then scale to $3M, then $7M.</a:t>
+              <a:t>Lead a firm that runs without me</a:t>
             </a:r>
           </a:p>
         </p:txBody>
@@ -6418,7 +6418,7 @@
                 </a:solidFill>
                 <a:latin typeface="Calibri"/>
               </a:rPr>
-              <a:t>Turn Google into a bilingual lead pipeline</a:t>
+              <a:t>Launch bilingual Google Ads in Allentown today</a:t>
             </a:r>
           </a:p>
         </p:txBody>
@@ -6541,7 +6541,7 @@
                 </a:solidFill>
                 <a:latin typeface="Calibri"/>
               </a:rPr>
-              <a:t>Fix NAP — activate 96 reviews in local pack</a:t>
+              <a:t>Enroll in LSA — 96 reviews wins top placement</a:t>
             </a:r>
           </a:p>
         </p:txBody>
@@ -6664,7 +6664,7 @@
                 </a:solidFill>
                 <a:latin typeface="Calibri"/>
               </a:rPr>
-              <a:t>Launch bilingual Spanish Ads for Allentown</a:t>
+              <a:t>Build Allentown geo pages to win the 3-pack</a:t>
             </a:r>
           </a:p>
         </p:txBody>
@@ -6787,7 +6787,7 @@
                 </a:solidFill>
                 <a:latin typeface="Calibri"/>
               </a:rPr>
-              <a:t>Enroll in LSA — appear above all Google ads</a:t>
+              <a:t>Rebuild website to fix the 14-second load time</a:t>
             </a:r>
           </a:p>
         </p:txBody>
@@ -6910,7 +6910,7 @@
                 </a:solidFill>
                 <a:latin typeface="Calibri"/>
               </a:rPr>
-              <a:t>Build city pages: Allentown, Bethlehem, Easton</a:t>
+              <a:t>Add Meta retargeting for missed site visits</a:t>
             </a:r>
           </a:p>
         </p:txBody>
@@ -7177,7 +7177,7 @@
                 </a:solidFill>
                 <a:latin typeface="Calibri"/>
               </a:rPr>
-              <a:t>Lift Gabby from 26.7% to Karen's 66% booking</a:t>
+              <a:t>Script Karen's 66% process for all intakers</a:t>
             </a:r>
           </a:p>
         </p:txBody>
@@ -7300,7 +7300,7 @@
                 </a:solidFill>
                 <a:latin typeface="Calibri"/>
               </a:rPr>
-              <a:t>Build lead nurture for 41 dead leads/month</a:t>
+              <a:t>Lift firm booking rate from 20% to 50%+</a:t>
             </a:r>
           </a:p>
         </p:txBody>
@@ -7423,7 +7423,7 @@
                 </a:solidFill>
                 <a:latin typeface="Calibri"/>
               </a:rPr>
-              <a:t>Add above-fold contact form to website</a:t>
+              <a:t>Train Gabby — her close rate already matches Karen</a:t>
             </a:r>
           </a:p>
         </p:txBody>
@@ -7546,7 +7546,7 @@
                 </a:solidFill>
                 <a:latin typeface="Calibri"/>
               </a:rPr>
-              <a:t>Add after-hours coverage for evening inquiries</a:t>
+              <a:t>Build after-hours protocol for Spanish callers</a:t>
             </a:r>
           </a:p>
         </p:txBody>
@@ -7669,7 +7669,7 @@
                 </a:solidFill>
                 <a:latin typeface="Calibri"/>
               </a:rPr>
-              <a:t>Weekly call review: build a team of Karens</a:t>
+              <a:t>Track every lead from first call to signed case</a:t>
             </a:r>
           </a:p>
         </p:txBody>
@@ -7936,7 +7936,7 @@
                 </a:solidFill>
                 <a:latin typeface="Calibri"/>
               </a:rPr>
-              <a:t>Hire removal attorney — capture 30% of leads</a:t>
+              <a:t>Plan second attorney hire with a financial model</a:t>
             </a:r>
           </a:p>
         </p:txBody>
@@ -8059,7 +8059,7 @@
                 </a:solidFill>
                 <a:latin typeface="Calibri"/>
               </a:rPr>
-              <a:t>Build case-type margin dashboard first</a:t>
+              <a:t>Keep the 30% referred-out cases in-house</a:t>
             </a:r>
           </a:p>
         </p:txBody>
@@ -8182,7 +8182,7 @@
                 </a:solidFill>
                 <a:latin typeface="Calibri"/>
               </a:rPr>
-              <a:t>Monthly profit plan toward $1M target</a:t>
+              <a:t>Build margin model by case type before scaling</a:t>
             </a:r>
           </a:p>
         </p:txBody>
@@ -8305,7 +8305,7 @@
                 </a:solidFill>
                 <a:latin typeface="Calibri"/>
               </a:rPr>
-              <a:t>Add manager layer as firm scales to $1M</a:t>
+              <a:t>Free Mahsa from decisions only she makes today</a:t>
             </a:r>
           </a:p>
         </p:txBody>
@@ -8428,7 +8428,7 @@
                 </a:solidFill>
                 <a:latin typeface="Calibri"/>
               </a:rPr>
-              <a:t>Expand removal ads once attorney is in place</a:t>
+              <a:t>Document 90-day onboarding for second attorney</a:t>
             </a:r>
           </a:p>
         </p:txBody>
@@ -8992,7 +8992,7 @@
                 </a:solidFill>
                 <a:latin typeface="Calibri"/>
               </a:rPr>
-              <a:t>Website rebuild · Bilingual Google Ads · LSA · Meta Ads · Local SEO</a:t>
+              <a:t>Website · Bilingual Google Ads · LSA · Meta · Local SEO</a:t>
             </a:r>
           </a:p>
         </p:txBody>
@@ -9292,7 +9292,7 @@
                 </a:solidFill>
                 <a:latin typeface="Calibri"/>
               </a:rPr>
-              <a:t>Weekly group coaching · KPI framework · Intake coaching · Masterminds</a:t>
+              <a:t>Weekly coaching · Intake conversion · Practice masterminds</a:t>
             </a:r>
           </a:p>
         </p:txBody>
@@ -9514,7 +9514,7 @@
                 </a:solidFill>
                 <a:latin typeface="Calibri"/>
               </a:rPr>
-              <a:t>+ Recommended ad spend: $4,000–$9,000/mo paid directly to Google/Meta</a:t>
+              <a:t>+ Recommended ad spend: $3,000–$12,000/mo paid directly to Google/Meta</a:t>
             </a:r>
           </a:p>
         </p:txBody>
@@ -9658,7 +9658,7 @@
                 </a:solidFill>
                 <a:latin typeface="Calibri"/>
               </a:rPr>
-              <a:t>~$5,250</a:t>
+              <a:t>~$5,000</a:t>
             </a:r>
           </a:p>
         </p:txBody>
@@ -9736,7 +9736,7 @@
                 </a:solidFill>
                 <a:latin typeface="Calibri"/>
               </a:rPr>
-              <a:t>Conservative  (~13 cases/mo):</a:t>
+              <a:t>Conservative  (2–3 cases/mo):</a:t>
             </a:r>
           </a:p>
         </p:txBody>
@@ -9769,7 +9769,7 @@
                 </a:solidFill>
                 <a:latin typeface="Calibri"/>
               </a:rPr>
-              <a:t>~$68,000 revenue · ~17× ROAS</a:t>
+              <a:t>$10K–$15K revenue · 3.3–5× ROAS</a:t>
             </a:r>
           </a:p>
         </p:txBody>
@@ -9802,7 +9802,7 @@
                 </a:solidFill>
                 <a:latin typeface="Calibri"/>
               </a:rPr>
-              <a:t>Aggressive  (~37 cases/mo):</a:t>
+              <a:t>Aggressive  (7–9 cases/mo):</a:t>
             </a:r>
           </a:p>
         </p:txBody>
@@ -9835,7 +9835,7 @@
                 </a:solidFill>
                 <a:latin typeface="Calibri"/>
               </a:rPr>
-              <a:t>~$194,000 revenue · ~22× ROAS</a:t>
+              <a:t>$35K–$45K revenue · 3–4× ROAS</a:t>
             </a:r>
           </a:p>
         </p:txBody>
@@ -9979,7 +9979,7 @@
                 </a:solidFill>
                 <a:latin typeface="Calibri"/>
               </a:rPr>
-              <a:t>Coaching kickoff; intake audit begins</a:t>
+              <a:t>Launch bilingual Google Ads for family immigration</a:t>
             </a:r>
           </a:p>
         </p:txBody>
@@ -10090,7 +10090,7 @@
                 </a:solidFill>
                 <a:latin typeface="Calibri"/>
               </a:rPr>
-              <a:t>Bilingual Google Ads + LSA setup live</a:t>
+              <a:t>Begin website rebuild: speed + geo-targeted pages</a:t>
             </a:r>
           </a:p>
         </p:txBody>
@@ -10201,7 +10201,7 @@
                 </a:solidFill>
                 <a:latin typeface="Calibri"/>
               </a:rPr>
-              <a:t>Website rebuild brief + city page plan</a:t>
+              <a:t>Apply for LSA Google Screened enrollment</a:t>
             </a:r>
           </a:p>
         </p:txBody>
@@ -10312,7 +10312,7 @@
                 </a:solidFill>
                 <a:latin typeface="Calibri"/>
               </a:rPr>
-              <a:t>NAP fixed; GBP post schedule active</a:t>
+              <a:t>Standardize intake script for all 3 intakers</a:t>
             </a:r>
           </a:p>
         </p:txBody>
@@ -10423,7 +10423,7 @@
                 </a:solidFill>
                 <a:latin typeface="Calibri"/>
               </a:rPr>
-              <a:t>Intake team at Karen's standard; $1M plan set</a:t>
+              <a:t>Elite Coach Plus: intake coaching + financial model</a:t>
             </a:r>
           </a:p>
         </p:txBody>
@@ -10501,7 +10501,7 @@
                 </a:solidFill>
                 <a:latin typeface="Calibri"/>
               </a:rPr>
-              <a:t>"I built the team. I have the SOPs. I have 96 five-star reviews. Now I need the market to find me — and a plan that takes me to $1M, $3M, and $7M."</a:t>
+              <a:t>“Marlen’s already handling my client emails. The next step is a firm where I’m leading — not the only person who can move a case forward.”</a:t>
             </a:r>
           </a:p>
         </p:txBody>

</xml_diff>